<commit_message>
fixed number and photos
</commit_message>
<xml_diff>
--- a/Capstone Poster Templates 25-26.pptx
+++ b/Capstone Poster Templates 25-26.pptx
@@ -280,6 +280,15 @@
     </p:ext>
   </p:extLst>
 </p:presentation>
+</file>
+
+<file path=ppt/revisionInfo.xml><?xml version="1.0" encoding="utf-8"?>
+<p1510:revInfo xmlns:a="http://schemas.openxmlformats.org/drawingml/2006/main" xmlns:r="http://schemas.openxmlformats.org/officeDocument/2006/relationships" xmlns:p1510="http://schemas.microsoft.com/office/powerpoint/2015/10/main">
+  <p1510:revLst>
+    <p1510:client id="{B6CE303D-6B7C-4806-AE57-4B232086ED5A}" v="6" dt="2025-11-13T17:45:35.215"/>
+    <p1510:client id="{C4815F6D-1D4B-4F27-9EE3-D2A37B638CF1}" v="77" dt="2025-11-13T17:42:49.377"/>
+  </p1510:revLst>
+</p1510:revInfo>
 </file>
 
 <file path=ppt/notesMasters/notesMaster1.xml><?xml version="1.0" encoding="utf-8"?>
@@ -5794,26 +5803,16 @@
               <a:buNone/>
             </a:pPr>
             <a:r>
-              <a:rPr lang="en" sz="10000">
+              <a:rPr lang="en" sz="10000" dirty="0">
                 <a:solidFill>
                   <a:schemeClr val="lt1"/>
                 </a:solidFill>
                 <a:latin typeface="Roboto Condensed ExtraBold"/>
                 <a:ea typeface="Roboto Condensed ExtraBold"/>
                 <a:cs typeface="Roboto Condensed ExtraBold"/>
-                <a:sym typeface="Roboto Condensed ExtraBold"/>
               </a:rPr>
-              <a:t>26-101</a:t>
-            </a:r>
-            <a:endParaRPr sz="10000">
-              <a:solidFill>
-                <a:schemeClr val="lt1"/>
-              </a:solidFill>
-              <a:latin typeface="Roboto Condensed ExtraBold"/>
-              <a:ea typeface="Roboto Condensed ExtraBold"/>
-              <a:cs typeface="Roboto Condensed ExtraBold"/>
-              <a:sym typeface="Roboto Condensed ExtraBold"/>
-            </a:endParaRPr>
+              <a:t>335</a:t>
+            </a:r>
           </a:p>
         </p:txBody>
       </p:sp>
@@ -6280,7 +6279,7 @@
         </p:nvSpPr>
         <p:spPr>
           <a:xfrm>
-            <a:off x="29411261" y="7417391"/>
+            <a:off x="29411261" y="7008467"/>
             <a:ext cx="11136086" cy="4708981"/>
           </a:xfrm>
           <a:prstGeom prst="rect">
@@ -6743,12 +6742,98 @@
           </a:p>
         </p:txBody>
       </p:sp>
+      <p:sp>
+        <p:nvSpPr>
+          <p:cNvPr id="2" name="TextBox 1">
+            <a:extLst>
+              <a:ext uri="{FF2B5EF4-FFF2-40B4-BE49-F238E27FC236}">
+                <a16:creationId xmlns:a16="http://schemas.microsoft.com/office/drawing/2014/main" id="{42330BC0-5C86-85AA-C788-048DE4BC8754}"/>
+              </a:ext>
+            </a:extLst>
+          </p:cNvPr>
+          <p:cNvSpPr txBox="1"/>
+          <p:nvPr/>
+        </p:nvSpPr>
+        <p:spPr>
+          <a:xfrm>
+            <a:off x="30559060" y="21851976"/>
+            <a:ext cx="5467676" cy="1046440"/>
+          </a:xfrm>
+          <a:prstGeom prst="rect">
+            <a:avLst/>
+          </a:prstGeom>
+          <a:noFill/>
+        </p:spPr>
+        <p:txBody>
+          <a:bodyPr rot="0" spcFirstLastPara="0" vertOverflow="overflow" horzOverflow="overflow" vert="horz" wrap="square" lIns="91440" tIns="45720" rIns="91440" bIns="45720" numCol="1" spcCol="0" rtlCol="0" fromWordArt="0" anchor="t" anchorCtr="0" forceAA="0" compatLnSpc="1">
+            <a:prstTxWarp prst="textNoShape">
+              <a:avLst/>
+            </a:prstTxWarp>
+            <a:spAutoFit/>
+          </a:bodyPr>
+          <a:lstStyle/>
+          <a:p>
+            <a:r>
+              <a:rPr lang="en-US" sz="4800" b="1" dirty="0"/>
+              <a:t>Goal Design</a:t>
+            </a:r>
+            <a:endParaRPr lang="en-US" dirty="0"/>
+          </a:p>
+          <a:p>
+            <a:pPr algn="ctr"/>
+            <a:endParaRPr lang="en-US"/>
+          </a:p>
+        </p:txBody>
+      </p:sp>
+      <p:sp>
+        <p:nvSpPr>
+          <p:cNvPr id="5" name="TextBox 4">
+            <a:extLst>
+              <a:ext uri="{FF2B5EF4-FFF2-40B4-BE49-F238E27FC236}">
+                <a16:creationId xmlns:a16="http://schemas.microsoft.com/office/drawing/2014/main" id="{4DFFB1CA-E567-B7EB-856D-16E3CAFC7F98}"/>
+              </a:ext>
+            </a:extLst>
+          </p:cNvPr>
+          <p:cNvSpPr txBox="1"/>
+          <p:nvPr/>
+        </p:nvSpPr>
+        <p:spPr>
+          <a:xfrm>
+            <a:off x="7864463" y="21851976"/>
+            <a:ext cx="5467676" cy="1046440"/>
+          </a:xfrm>
+          <a:prstGeom prst="rect">
+            <a:avLst/>
+          </a:prstGeom>
+          <a:noFill/>
+        </p:spPr>
+        <p:txBody>
+          <a:bodyPr rot="0" spcFirstLastPara="0" vertOverflow="overflow" horzOverflow="overflow" vert="horz" wrap="square" lIns="91440" tIns="45720" rIns="91440" bIns="45720" numCol="1" spcCol="0" rtlCol="0" fromWordArt="0" anchor="t" anchorCtr="0" forceAA="0" compatLnSpc="1">
+            <a:prstTxWarp prst="textNoShape">
+              <a:avLst/>
+            </a:prstTxWarp>
+            <a:spAutoFit/>
+          </a:bodyPr>
+          <a:lstStyle/>
+          <a:p>
+            <a:r>
+              <a:rPr lang="en-US" sz="4800" b="1" dirty="0"/>
+              <a:t>Current Design</a:t>
+            </a:r>
+            <a:endParaRPr lang="en-US" dirty="0"/>
+          </a:p>
+          <a:p>
+            <a:pPr algn="ctr"/>
+            <a:endParaRPr lang="en-US"/>
+          </a:p>
+        </p:txBody>
+      </p:sp>
       <p:pic>
         <p:nvPicPr>
-          <p:cNvPr id="4" name="Picture 3" descr="A video game graphics of a video game&#10;&#10;AI-generated content may be incorrect.">
+          <p:cNvPr id="10" name="Picture 9">
             <a:extLst>
               <a:ext uri="{FF2B5EF4-FFF2-40B4-BE49-F238E27FC236}">
-                <a16:creationId xmlns:a16="http://schemas.microsoft.com/office/drawing/2014/main" id="{00DB6384-07C6-E9E4-A2C0-DFDE96EDE07D}"/>
+                <a16:creationId xmlns:a16="http://schemas.microsoft.com/office/drawing/2014/main" id="{316BF65B-4F0F-B606-7703-CB284326C075}"/>
               </a:ext>
             </a:extLst>
           </p:cNvPr>
@@ -6765,25 +6850,32 @@
         </p:blipFill>
         <p:spPr>
           <a:xfrm>
-            <a:off x="1320799" y="22806219"/>
-            <a:ext cx="18266611" cy="5898663"/>
+            <a:off x="23426888" y="22903347"/>
+            <a:ext cx="19147890" cy="7005630"/>
           </a:xfrm>
           <a:prstGeom prst="rect">
             <a:avLst/>
           </a:prstGeom>
-          <a:ln w="12700">
+          <a:ln w="228600" cap="sq" cmpd="thickThin">
             <a:solidFill>
-              <a:schemeClr val="tx1"/>
+              <a:srgbClr val="000000"/>
             </a:solidFill>
+            <a:prstDash val="solid"/>
+            <a:miter lim="800000"/>
           </a:ln>
+          <a:effectLst>
+            <a:innerShdw blurRad="76200">
+              <a:srgbClr val="000000"/>
+            </a:innerShdw>
+          </a:effectLst>
         </p:spPr>
       </p:pic>
       <p:pic>
         <p:nvPicPr>
-          <p:cNvPr id="12" name="Picture 11" descr="A screenshot of a video game&#10;&#10;AI-generated content may be incorrect.">
+          <p:cNvPr id="11" name="Picture 10">
             <a:extLst>
               <a:ext uri="{FF2B5EF4-FFF2-40B4-BE49-F238E27FC236}">
-                <a16:creationId xmlns:a16="http://schemas.microsoft.com/office/drawing/2014/main" id="{6BB9AC85-43FC-D187-BDCE-060A8E9D6713}"/>
+                <a16:creationId xmlns:a16="http://schemas.microsoft.com/office/drawing/2014/main" id="{D28300BF-DF68-8118-9A7A-97F9A1C56311}"/>
               </a:ext>
             </a:extLst>
           </p:cNvPr>
@@ -6800,17 +6892,24 @@
         </p:blipFill>
         <p:spPr>
           <a:xfrm>
-            <a:off x="23227281" y="22806219"/>
-            <a:ext cx="18266611" cy="5898663"/>
+            <a:off x="1476709" y="22896573"/>
+            <a:ext cx="19321916" cy="4820954"/>
           </a:xfrm>
           <a:prstGeom prst="rect">
             <a:avLst/>
           </a:prstGeom>
-          <a:ln w="12700">
+          <a:ln w="228600" cap="sq" cmpd="thickThin">
             <a:solidFill>
-              <a:schemeClr val="tx1"/>
+              <a:srgbClr val="000000"/>
             </a:solidFill>
+            <a:prstDash val="solid"/>
+            <a:miter lim="800000"/>
           </a:ln>
+          <a:effectLst>
+            <a:innerShdw blurRad="76200">
+              <a:srgbClr val="000000"/>
+            </a:innerShdw>
+          </a:effectLst>
         </p:spPr>
       </p:pic>
     </p:spTree>

</xml_diff>